<commit_message>
Add 45-word speaking notes (Word) and sync slide notes
Co-Authored-By: Claude Sonnet 5.5 <noreply@anthropic.com>
Claude-Session: https://claude.ai/code/session_01CwactU9unRHd2XFUYEderG
</commit_message>
<xml_diff>
--- a/UK_Air_Quality_Thesis_Proposal.pptx
+++ b/UK_Air_Quality_Thesis_Proposal.pptx
@@ -1189,7 +1189,7 @@
           <a:p>
             <a:r>
               <a:rPr lang="en-US" dirty="0"/>
-              <a:t>Introduce yourself and the topic. State that this is a secondary, qualitative, interpretivist study of air quality management in major UK cities. The three figures on the right preview the evidence base: pollution is falling (Weber &amp; Dacre, 2025; Gadenne et al., 2024), but the question is what role management plays in sustainable urban development. About 40 seconds.</a:t>
+              <a:t>Hello. My proposal evaluates how air quality management advances sustainable urban development, using evidence from major UK cities. I take an interpretivist, qualitative approach with secondary data. These figures, from Weber and Dacre, 2025, and Gadenne and colleagues, 2024, show pollution falling, yet questions remain.</a:t>
             </a:r>
             <a:endParaRPr lang="en-US" dirty="0"/>
           </a:p>
@@ -1277,7 +1277,7 @@
           <a:p>
             <a:r>
               <a:rPr lang="en-US" dirty="0"/>
-              <a:t>All sources are listed in APA 7th edition. Ten are from 2020 onwards; the UN (2015) is included for the SDG 11.6 framing and the OHID page is undated. DOIs are given where available and URLs for official publications. Close by restating the aim and inviting questions.</a:t>
+              <a:t>My references combine peer-reviewed journals, WHO guidance, legislation and official reports, in APA seventh edition. In conclusion, this study will clearly explain how air quality management contributes to sustainable urban development in major UK cities. Thank you very much for listening; I welcome any questions.</a:t>
             </a:r>
             <a:endParaRPr lang="en-US" dirty="0"/>
           </a:p>
@@ -1365,7 +1365,7 @@
           <a:p>
             <a:r>
               <a:rPr lang="en-US" dirty="0"/>
-              <a:t>Background. The headline is progress: NO2 breach days fall from a median of 136 to 40 per site and PM2.5 from 60 to 22 (Weber &amp; Dacre, 2025), and average PM2.5 exposure in England fell 54% (Gadenne et al., 2024). But the WHO (2021) guideline is much stricter than the 10 µg/m3 legal target in the 2023 Regulations, and ozone breach days actually doubled. Health burden is from OHID. About 70 seconds.</a:t>
+              <a:t>UK air quality is improving. Weber and Dacre, 2025, found median days breaching WHO limits fell from 136 to 40 for nitrogen dioxide, and from 60 to 22 for fine particulates. The WHO, 2021, guideline is stricter than England's legal target, and ozone breaches doubled.</a:t>
             </a:r>
             <a:endParaRPr lang="en-US" dirty="0"/>
           </a:p>
@@ -1453,7 +1453,7 @@
           <a:p>
             <a:r>
               <a:rPr lang="en-US" dirty="0"/>
-              <a:t>The problem statement. Pollutant concentrations are improving, but three issues remain: guideline breaches persist, exposure is unequal, and the effects of local measures are inconsistent. London's ULEZ is estimated by TfL (2025) to have cut roadside NO2 by 27% against a no-ULEZ scenario, while Sheffield's CAZ shows no significant zone-specific effect (Williams et al., 2025). What we lack is an interpretive account of how these measures are framed and justified in terms of sustainable development. About 60 seconds.</a:t>
+              <a:t>Pollution is falling, yet guideline breaches persist, exposure is unequal, and measures show mixed results. London's ULEZ cut roadside nitrogen dioxide by an estimated twenty-seven percent, Transport for London, 2025, while Sheffield's zone showed no significant effect, Williams and colleagues, 2025. Wider impact remains unclear.</a:t>
             </a:r>
             <a:endParaRPr lang="en-US" dirty="0"/>
           </a:p>
@@ -1541,7 +1541,7 @@
           <a:p>
             <a:r>
               <a:rPr lang="en-US" dirty="0"/>
-              <a:t>Literature and gap. Five recent sources cover trends, exposure inequality and the effects of the Birmingham, Sheffield and London schemes. They are valuable but quantitative and outcome-focused. I am not claiming no other work exists; I am saying the gap is a cross-city interpretive synthesis linking air quality management to sustainable-development dimensions, and the Week 1 to 2 scoping search will test this. About 70 seconds.</a:t>
+              <a:t>Studies measure national trends, exposure inequality, and individual city schemes in Birmingham, Sheffield and London. They are quantitative and outcome-focused. The gap is a cross-city, interpretive synthesis of how air quality management is framed and justified within sustainable development, which my scoping search will confirm.</a:t>
             </a:r>
             <a:endParaRPr lang="en-US" dirty="0"/>
           </a:p>
@@ -1629,7 +1629,7 @@
           <a:p>
             <a:r>
               <a:rPr lang="en-US" dirty="0"/>
-              <a:t>Aim, objectives and questions. The framework on the right is my own synthesis of the sources: standards (WHO, 2021; Regulations 2023) shape city measures (e.g., ULEZ, CAZ), which are expected to contribute to sustainable urban development as framed in SDG 11.6 (UN, 2015). Because the approach is inductive, these dimensions only sensitise me; the themes themselves will be generated from the data. About 70 seconds.</a:t>
+              <a:t>My aim is to evaluate how air quality management is framed and implemented in major UK cities, and its role in sustainable development. Four objectives and three research questions guide me. The framework links standards, city measures and sustainability outcomes, following the United Nations, 2015.</a:t>
             </a:r>
             <a:endParaRPr lang="en-US" dirty="0"/>
           </a:p>
@@ -1717,7 +1717,7 @@
           <a:p>
             <a:r>
               <a:rPr lang="en-US" dirty="0"/>
-              <a:t>This is the Research Onion (Saunders et al., 2023), peeled from the outside in. Philosophy: interpretivism, because I treat air quality management as a socially constructed policy field whose meaning is expressed in documents. Approach: inductive. Choice: mono-method qualitative. Strategy: archival and documentary research. Time horizon: cross-sectional. Techniques: secondary data and thematic analysis (Braun &amp; Clarke, 2021). About 60 seconds.</a:t>
+              <a:t>Using the Research Onion of Saunders and colleagues, 2023: my philosophy is interpretivism, my approach is inductive, and my choice is qualitative mono-method. The strategy is archival and documentary research, the time horizon is cross-sectional, and my techniques are secondary data and reflexive thematic analysis.</a:t>
             </a:r>
             <a:endParaRPr lang="en-US" dirty="0"/>
           </a:p>
@@ -1805,7 +1805,7 @@
           <a:p>
             <a:r>
               <a:rPr lang="en-US" dirty="0"/>
-              <a:t>Data sources and selection. The corpus is official: Defra and UK-AIR, DfT, ONS, and city authority Annual Status Reports and scheme evaluations, plus peer-reviewed papers. Newspapers are used only to triangulate how measures are publicly framed. Criteria: 2020 onwards, major UK city, about air quality management, official or peer-reviewed and publicly accessible. The funnel shows identify, screen, assess eligibility, include. About 60 seconds.</a:t>
+              <a:t>I will use official and peer-reviewed secondary sources: Defra, the Department for Transport, the Office for National Statistics, city authority reports, and journal articles. Newspapers only help triangulate. I include material from 2020 onwards covering major UK cities, and exclude unsourced, non-UK or duplicate documents.</a:t>
             </a:r>
             <a:endParaRPr lang="en-US" dirty="0"/>
           </a:p>
@@ -1893,7 +1893,7 @@
           <a:p>
             <a:r>
               <a:rPr lang="en-US" dirty="0"/>
-              <a:t>The analysis follows Braun and Clarke's (2021) six phases of reflexive thematic analysis. Because the approach is inductive, coding stays close to what the documents say. Each phase produces a tangible output, which supports transparency. I acknowledge limitations: documents are institutional and silent on residents' voices. About 70 seconds.</a:t>
+              <a:t>I will follow Braun and Clarke's, 2021, six phases: familiarisation, inductive coding, generating themes, reviewing themes, defining and naming themes, and writing up. A reflexive journal and audit trail support methodological rigour, although the documents carry no stakeholder voices, which I acknowledge as a limitation.</a:t>
             </a:r>
             <a:endParaRPr lang="en-US" dirty="0"/>
           </a:p>
@@ -1981,7 +1981,7 @@
           <a:p>
             <a:r>
               <a:rPr lang="en-US" dirty="0"/>
-              <a:t>Six-week plan. Weeks 1 to 2 for scoping, protocol and literature; weeks 2 to 3 for search and screening; weeks 3 to 5 for coding and theme development per Braun and Clarke (2021); weeks 5 to 6 for synthesis, write-up and recording. The contribution is theoretical, practical, equity-focused and methodological, with the caveat that findings are interpretive and context-bound. About 60 seconds.</a:t>
+              <a:t>Over six weeks, I will scope and review literature, screen documents, code them, develop themes, then write up and record. The expected contribution is theoretical, linking management to sustainable development; practical, offering cross-city lessons; equity-focused, addressing exposure inequalities; and methodological, providing transparent documentary thematic analysis.</a:t>
             </a:r>
             <a:endParaRPr lang="en-US" dirty="0"/>
           </a:p>

</xml_diff>